<commit_message>
Migration ouvalargent.fr → ouvalargent.com + réorganisation projet
- Remplacement de toutes les références .fr → .com (183 occurrences, ~75 fichiers)
- Ré-export des 47 infographies en 3 formats (141 PNG)
- Correction des PPTX (template-rapport + rapport Guyane)
- Nouvelles bannières : LinkedIn, wallpapers desktop & phone
- Réorganisation : suppression dossiers parasites, déplacement fact-checks et scripts
- Nettoyage : suppression Site_old/, screenshots orphelins, images inutiles
- Déplacement couvertures/logos → Templates/Bannière & logo/

Co-Authored-By: Claude Opus 4.6 <noreply@anthropic.com>
</commit_message>
<xml_diff>
--- a/Templates/PPT/Rapport/template-rapport.pptx
+++ b/Templates/PPT/Rapport/template-rapport.pptx
@@ -3028,7 +3028,7 @@
                 <a:ea typeface="JetBrains Mono" pitchFamily="34" charset="-122"/>
                 <a:cs typeface="JetBrains Mono" pitchFamily="34" charset="-120"/>
               </a:rPr>
-              <a:t>ouvalargent.fr</a:t>
+              <a:t>ouvalargent.com</a:t>
             </a:r>
             <a:endParaRPr lang="en-US" sz="1100" dirty="0"/>
           </a:p>
@@ -3732,7 +3732,7 @@
                 <a:ea typeface="JetBrains Mono" pitchFamily="34" charset="-122"/>
                 <a:cs typeface="JetBrains Mono" pitchFamily="34" charset="-120"/>
               </a:rPr>
-              <a:t>ouvalargent.fr</a:t>
+              <a:t>ouvalargent.com</a:t>
             </a:r>
             <a:endParaRPr lang="en-US" sz="1100" dirty="0"/>
           </a:p>
@@ -6006,7 +6006,7 @@
                 <a:ea typeface="JetBrains Mono" pitchFamily="34" charset="-122"/>
                 <a:cs typeface="JetBrains Mono" pitchFamily="34" charset="-120"/>
               </a:rPr>
-              <a:t>ouvalargent.fr</a:t>
+              <a:t>ouvalargent.com</a:t>
             </a:r>
             <a:endParaRPr lang="en-US" sz="1100" dirty="0"/>
           </a:p>
@@ -7427,7 +7427,7 @@
                 <a:ea typeface="JetBrains Mono" pitchFamily="34" charset="-122"/>
                 <a:cs typeface="JetBrains Mono" pitchFamily="34" charset="-120"/>
               </a:rPr>
-              <a:t>ouvalargent.fr</a:t>
+              <a:t>ouvalargent.com</a:t>
             </a:r>
             <a:endParaRPr lang="en-US" sz="1100" dirty="0"/>
           </a:p>
@@ -9007,7 +9007,7 @@
                 <a:ea typeface="JetBrains Mono" pitchFamily="34" charset="-122"/>
                 <a:cs typeface="JetBrains Mono" pitchFamily="34" charset="-120"/>
               </a:rPr>
-              <a:t>ouvalargent.fr</a:t>
+              <a:t>ouvalargent.com</a:t>
             </a:r>
             <a:pPr algn="ctr" indent="0" marL="0">
               <a:buNone/>
@@ -9027,7 +9027,7 @@
                 <a:ea typeface="JetBrains Mono" pitchFamily="34" charset="-122"/>
                 <a:cs typeface="JetBrains Mono" pitchFamily="34" charset="-120"/>
               </a:rPr>
-              <a:t>contact@ouvalargent.fr</a:t>
+              <a:t>contact@ouvalargent.com</a:t>
             </a:r>
             <a:endParaRPr lang="en-US" sz="1400" dirty="0"/>
           </a:p>
@@ -9678,7 +9678,7 @@
                 <a:ea typeface="JetBrains Mono" pitchFamily="34" charset="-122"/>
                 <a:cs typeface="JetBrains Mono" pitchFamily="34" charset="-120"/>
               </a:rPr>
-              <a:t>ouvalargent.fr</a:t>
+              <a:t>ouvalargent.com</a:t>
             </a:r>
             <a:endParaRPr lang="en-US" sz="1100" dirty="0"/>
           </a:p>
@@ -11437,7 +11437,7 @@
                 <a:ea typeface="JetBrains Mono" pitchFamily="34" charset="-122"/>
                 <a:cs typeface="JetBrains Mono" pitchFamily="34" charset="-120"/>
               </a:rPr>
-              <a:t>ouvalargent.fr</a:t>
+              <a:t>ouvalargent.com</a:t>
             </a:r>
             <a:endParaRPr lang="en-US" sz="1100" dirty="0"/>
           </a:p>
@@ -13318,7 +13318,7 @@
                 <a:ea typeface="JetBrains Mono" pitchFamily="34" charset="-122"/>
                 <a:cs typeface="JetBrains Mono" pitchFamily="34" charset="-120"/>
               </a:rPr>
-              <a:t>ouvalargent.fr</a:t>
+              <a:t>ouvalargent.com</a:t>
             </a:r>
             <a:endParaRPr lang="en-US" sz="1100" dirty="0"/>
           </a:p>
@@ -15456,7 +15456,7 @@
                 <a:ea typeface="JetBrains Mono" pitchFamily="34" charset="-122"/>
                 <a:cs typeface="JetBrains Mono" pitchFamily="34" charset="-120"/>
               </a:rPr>
-              <a:t>ouvalargent.fr</a:t>
+              <a:t>ouvalargent.com</a:t>
             </a:r>
             <a:endParaRPr lang="en-US" sz="1100" dirty="0"/>
           </a:p>
@@ -16588,7 +16588,7 @@
                 <a:ea typeface="JetBrains Mono" pitchFamily="34" charset="-122"/>
                 <a:cs typeface="JetBrains Mono" pitchFamily="34" charset="-120"/>
               </a:rPr>
-              <a:t>ouvalargent.fr</a:t>
+              <a:t>ouvalargent.com</a:t>
             </a:r>
             <a:endParaRPr lang="en-US" sz="1100" dirty="0"/>
           </a:p>
@@ -21094,7 +21094,7 @@
                 <a:ea typeface="JetBrains Mono" pitchFamily="34" charset="-122"/>
                 <a:cs typeface="JetBrains Mono" pitchFamily="34" charset="-120"/>
               </a:rPr>
-              <a:t>ouvalargent.fr</a:t>
+              <a:t>ouvalargent.com</a:t>
             </a:r>
             <a:endParaRPr lang="en-US" sz="1100" dirty="0"/>
           </a:p>
@@ -22906,7 +22906,7 @@
                 <a:ea typeface="JetBrains Mono" pitchFamily="34" charset="-122"/>
                 <a:cs typeface="JetBrains Mono" pitchFamily="34" charset="-120"/>
               </a:rPr>
-              <a:t>ouvalargent.fr</a:t>
+              <a:t>ouvalargent.com</a:t>
             </a:r>
             <a:endParaRPr lang="en-US" sz="1100" dirty="0"/>
           </a:p>

</xml_diff>